<commit_message>
Deploy documentation from 2d551ebf5118279bcef55d78b907e443260ffd55
</commit_message>
<xml_diff>
--- a/presentations/introduction-to-edumatcher.pptx
+++ b/presentations/introduction-to-edumatcher.pptx
@@ -237,7 +237,7 @@
           <a:p>
             <a:fld id="{5282F153-3F37-0F45-9E97-73ACFA13230C}" type="datetimeFigureOut">
               <a:rPr lang="en-US"/>
-              <a:t>8/5/26</a:t>
+              <a:t>8/7/26</a:t>
             </a:fld>
             <a:endParaRPr lang="en-US"/>
           </a:p>
@@ -3468,7 +3468,10 @@
           <a:bodyPr/>
           <a:lstStyle/>
           <a:p>
-            <a:endParaRPr lang="en-SE" dirty="0"/>
+            <a:r>
+              <a:rPr lang="en-SE" dirty="0"/>
+              <a:t>J</a:t>
+            </a:r>
           </a:p>
         </p:txBody>
       </p:sp>
@@ -3632,6 +3635,48 @@
               <a:t>A fully functional exchange matching engine — built for learning, research, and demonstration. Real order-book mechanics, auctions, risk controls, and a ZeroMQ message bus.</a:t>
             </a:r>
             <a:endParaRPr lang="en-US" sz="1250" dirty="0"/>
+          </a:p>
+        </p:txBody>
+      </p:sp>
+      <p:sp>
+        <p:nvSpPr>
+          <p:cNvPr id="8" name="TextBox 7">
+            <a:extLst>
+              <a:ext uri="{FF2B5EF4-FFF2-40B4-BE49-F238E27FC236}">
+                <a16:creationId xmlns:a16="http://schemas.microsoft.com/office/drawing/2014/main" id="{32C33A31-178C-01A0-34CC-415C91FF617F}"/>
+              </a:ext>
+            </a:extLst>
+          </p:cNvPr>
+          <p:cNvSpPr txBox="1"/>
+          <p:nvPr/>
+        </p:nvSpPr>
+        <p:spPr>
+          <a:xfrm>
+            <a:off x="7342701" y="4752898"/>
+            <a:ext cx="1718797" cy="307777"/>
+          </a:xfrm>
+          <a:prstGeom prst="rect">
+            <a:avLst/>
+          </a:prstGeom>
+          <a:noFill/>
+        </p:spPr>
+        <p:txBody>
+          <a:bodyPr wrap="square" rtlCol="0">
+            <a:spAutoFit/>
+          </a:bodyPr>
+          <a:lstStyle/>
+          <a:p>
+            <a:pPr algn="r"/>
+            <a:r>
+              <a:rPr lang="en-SE" sz="1400" i="1" dirty="0">
+                <a:solidFill>
+                  <a:schemeClr val="bg1">
+                    <a:lumMod val="50000"/>
+                  </a:schemeClr>
+                </a:solidFill>
+              </a:rPr>
+              <a:t>J. Persson, 2026</a:t>
+            </a:r>
           </a:p>
         </p:txBody>
       </p:sp>

</xml_diff>